<commit_message>
First cycle: categories (causes, effects, problems, solutions, advantages...) become sub-headings with listed points; GCE-style temperature profile of the atmosphere
Co-Authored-By: Claude Opus 5.5 <noreply@anthropic.com>
Claude-Session: https://claude.ai/code/session_0115LFSb2ktGLWPeVksFkSer
</commit_message>
<xml_diff>
--- a/lecons/F1/13_F1_M3_L07_The_Atmosphere.pptx
+++ b/lecons/F1/13_F1_M3_L07_The_Atmosphere.pptx
@@ -14299,7 +14299,7 @@
       </p:sp>
       <p:pic>
         <p:nvPicPr>
-          <p:cNvPr id="5" name="Image 0" descr="/home/claude/f4/img/v2/atmosphere_big.png">    </p:cNvPr>
+          <p:cNvPr id="5" name="Image 0" descr="/home/claude/f4/img/v2/atm_profile_gce.png">    </p:cNvPr>
           <p:cNvPicPr>
             <a:picLocks noChangeAspect="1"/>
           </p:cNvPicPr>
@@ -14313,8 +14313,8 @@
         </p:blipFill>
         <p:spPr>
           <a:xfrm>
-            <a:off x="5349240" y="2617506"/>
-            <a:ext cx="6659575" cy="2601397"/>
+            <a:off x="6358241" y="1783080"/>
+            <a:ext cx="4641574" cy="4270248"/>
           </a:xfrm>
           <a:prstGeom prst="rect">
             <a:avLst/>

</xml_diff>